<commit_message>
Big Data IoT Python UniRuy Wyden ...
</commit_message>
<xml_diff>
--- a/01 Classes/Aula 10 - Aplicação Cloud Indústria 40 Python Integração Cloud Big Data Parte 1.pptx
+++ b/01 Classes/Aula 10 - Aplicação Cloud Indústria 40 Python Integração Cloud Big Data Parte 1.pptx
@@ -4986,7 +4986,7 @@
                 <a:latin typeface="Times New Roman" panose="02020603050405020304" pitchFamily="18" charset="0"/>
                 <a:cs typeface="Times New Roman" panose="02020603050405020304" pitchFamily="18" charset="0"/>
               </a:rPr>
-              <a:t>Um </a:t>
+              <a:t>	Um </a:t>
             </a:r>
             <a:r>
               <a:rPr lang="pt-BR" sz="2000" b="1" dirty="0">
@@ -5017,7 +5017,7 @@
                 <a:latin typeface="Times New Roman" panose="02020603050405020304" pitchFamily="18" charset="0"/>
                 <a:cs typeface="Times New Roman" panose="02020603050405020304" pitchFamily="18" charset="0"/>
               </a:rPr>
-              <a:t> que pode ser aplicada a uma grande quantidade de dados variados. </a:t>
+              <a:t> que pode ser aplicada a uma grande quantidade de dados variados.</a:t>
             </a:r>
           </a:p>
           <a:p>
@@ -5090,7 +5090,7 @@
                 <a:latin typeface="Times New Roman" panose="02020603050405020304" pitchFamily="18" charset="0"/>
                 <a:cs typeface="Times New Roman" panose="02020603050405020304" pitchFamily="18" charset="0"/>
               </a:rPr>
-              <a:t>É como se fosse possível </a:t>
+              <a:t>	É como se fosse possível </a:t>
             </a:r>
             <a:r>
               <a:rPr lang="pt-BR" sz="2000" b="1" dirty="0">
@@ -5138,18 +5138,11 @@
               <a:buNone/>
             </a:pPr>
             <a:r>
-              <a:rPr lang="pt-BR" sz="2000" dirty="0">
-                <a:latin typeface="Times New Roman" panose="02020603050405020304" pitchFamily="18" charset="0"/>
-                <a:cs typeface="Times New Roman" panose="02020603050405020304" pitchFamily="18" charset="0"/>
-              </a:rPr>
-              <a:t>O </a:t>
-            </a:r>
-            <a:r>
               <a:rPr lang="pt-BR" sz="2000" b="1" dirty="0">
                 <a:latin typeface="Times New Roman" panose="02020603050405020304" pitchFamily="18" charset="0"/>
                 <a:cs typeface="Times New Roman" panose="02020603050405020304" pitchFamily="18" charset="0"/>
               </a:rPr>
-              <a:t>Python</a:t>
+              <a:t>	Python</a:t>
             </a:r>
             <a:r>
               <a:rPr lang="pt-BR" sz="2000" dirty="0">
@@ -5284,14 +5277,14 @@
                 <a:latin typeface="Times New Roman" panose="02020603050405020304" pitchFamily="18" charset="0"/>
                 <a:cs typeface="Times New Roman" panose="02020603050405020304" pitchFamily="18" charset="0"/>
               </a:rPr>
-              <a:t>Python</a:t>
-            </a:r>
-            <a:r>
-              <a:rPr lang="pt-BR" sz="2000" dirty="0">
-                <a:latin typeface="Times New Roman" panose="02020603050405020304" pitchFamily="18" charset="0"/>
-                <a:cs typeface="Times New Roman" panose="02020603050405020304" pitchFamily="18" charset="0"/>
-              </a:rPr>
-              <a:t> é mais próxima da “visão” humana do que da máquina, tem muitas </a:t>
+              <a:t>	Python</a:t>
+            </a:r>
+            <a:r>
+              <a:rPr lang="pt-BR" sz="2000" dirty="0">
+                <a:latin typeface="Times New Roman" panose="02020603050405020304" pitchFamily="18" charset="0"/>
+                <a:cs typeface="Times New Roman" panose="02020603050405020304" pitchFamily="18" charset="0"/>
+              </a:rPr>
+              <a:t> é mais próxima da “</a:t>
             </a:r>
             <a:r>
               <a:rPr lang="pt-BR" sz="2000" b="1" dirty="0">
@@ -5301,6 +5294,23 @@
                 <a:latin typeface="Times New Roman" panose="02020603050405020304" pitchFamily="18" charset="0"/>
                 <a:cs typeface="Times New Roman" panose="02020603050405020304" pitchFamily="18" charset="0"/>
               </a:rPr>
+              <a:t>visão</a:t>
+            </a:r>
+            <a:r>
+              <a:rPr lang="pt-BR" sz="2000" dirty="0">
+                <a:latin typeface="Times New Roman" panose="02020603050405020304" pitchFamily="18" charset="0"/>
+                <a:cs typeface="Times New Roman" panose="02020603050405020304" pitchFamily="18" charset="0"/>
+              </a:rPr>
+              <a:t>” humana do que da máquina, tem muitas </a:t>
+            </a:r>
+            <a:r>
+              <a:rPr lang="pt-BR" sz="2000" b="1" dirty="0">
+                <a:solidFill>
+                  <a:srgbClr val="FF0000"/>
+                </a:solidFill>
+                <a:latin typeface="Times New Roman" panose="02020603050405020304" pitchFamily="18" charset="0"/>
+                <a:cs typeface="Times New Roman" panose="02020603050405020304" pitchFamily="18" charset="0"/>
+              </a:rPr>
               <a:t>bibliotecas nativas e de terceiros</a:t>
             </a:r>
             <a:r>
@@ -5325,18 +5335,11 @@
               <a:t>(Inteligência Artificial), </a:t>
             </a:r>
             <a:r>
-              <a:rPr lang="pt-BR" sz="2000" b="1" dirty="0" err="1">
-                <a:latin typeface="Times New Roman" panose="02020603050405020304" pitchFamily="18" charset="0"/>
-                <a:cs typeface="Times New Roman" panose="02020603050405020304" pitchFamily="18" charset="0"/>
-              </a:rPr>
-              <a:t>Machine</a:t>
-            </a:r>
-            <a:r>
               <a:rPr lang="pt-BR" sz="2000" b="1" dirty="0">
                 <a:latin typeface="Times New Roman" panose="02020603050405020304" pitchFamily="18" charset="0"/>
                 <a:cs typeface="Times New Roman" panose="02020603050405020304" pitchFamily="18" charset="0"/>
               </a:rPr>
-              <a:t> Learning</a:t>
+              <a:t>Machine Learning</a:t>
             </a:r>
             <a:r>
               <a:rPr lang="pt-BR" sz="2000" dirty="0">
@@ -5378,7 +5381,7 @@
                 <a:latin typeface="Times New Roman" panose="02020603050405020304" pitchFamily="18" charset="0"/>
                 <a:cs typeface="Times New Roman" panose="02020603050405020304" pitchFamily="18" charset="0"/>
               </a:rPr>
-              <a:t>Além disso, pode ser utilizada não apenas por </a:t>
+              <a:t>	Além disso, pode ser utilizada não apenas por </a:t>
             </a:r>
             <a:r>
               <a:rPr lang="pt-BR" sz="2000" b="1" dirty="0">
@@ -5436,7 +5439,7 @@
                 <a:latin typeface="Times New Roman" panose="02020603050405020304" pitchFamily="18" charset="0"/>
                 <a:cs typeface="Times New Roman" panose="02020603050405020304" pitchFamily="18" charset="0"/>
               </a:rPr>
-              <a:t>Outro detalhe a ser observado é que os </a:t>
+              <a:t>	Outro detalhe a ser observado é que os </a:t>
             </a:r>
             <a:r>
               <a:rPr lang="pt-BR" sz="2000" b="1" dirty="0">
@@ -5592,7 +5595,7 @@
         </p:nvSpPr>
         <p:spPr>
           <a:xfrm>
-            <a:off x="142865" y="1200150"/>
+            <a:off x="142865" y="984998"/>
             <a:ext cx="8865056" cy="3737370"/>
           </a:xfrm>
         </p:spPr>
@@ -5669,23 +5672,8 @@
                 <a:cs typeface="Times New Roman" panose="02020603050405020304" pitchFamily="18" charset="0"/>
                 <a:hlinkClick r:id="rId3"/>
               </a:rPr>
-              <a:t>https://www.edureka.co/big-data-hadoop-training-certification-bangalore</a:t>
-            </a:r>
-            <a:r>
-              <a:rPr lang="pt-BR" sz="2000" dirty="0">
-                <a:solidFill>
-                  <a:schemeClr val="tx1"/>
-                </a:solidFill>
-                <a:latin typeface="Times New Roman" panose="02020603050405020304" pitchFamily="18" charset="0"/>
-                <a:cs typeface="Times New Roman" panose="02020603050405020304" pitchFamily="18" charset="0"/>
-              </a:rPr>
-              <a:t> </a:t>
-            </a:r>
-          </a:p>
-          <a:p>
-            <a:pPr marL="0" indent="0" algn="just">
-              <a:buNone/>
-            </a:pPr>
+              <a:t>https://spark.apache.org/docs/latest/api/python/</a:t>
+            </a:r>
             <a:endParaRPr lang="pt-BR" sz="2000" dirty="0">
               <a:solidFill>
                 <a:schemeClr val="tx1"/>
@@ -5699,14 +5687,14 @@
               <a:buNone/>
             </a:pPr>
             <a:r>
-              <a:rPr lang="pt-BR" sz="2000" b="1" dirty="0">
+              <a:rPr lang="pt-BR" sz="2000" dirty="0">
                 <a:solidFill>
                   <a:schemeClr val="tx1"/>
                 </a:solidFill>
                 <a:latin typeface="Times New Roman" panose="02020603050405020304" pitchFamily="18" charset="0"/>
                 <a:cs typeface="Times New Roman" panose="02020603050405020304" pitchFamily="18" charset="0"/>
               </a:rPr>
-              <a:t>Java</a:t>
+              <a:t>	 </a:t>
             </a:r>
             <a:r>
               <a:rPr lang="pt-BR" sz="2000" dirty="0">
@@ -5715,18 +5703,9 @@
                 </a:solidFill>
                 <a:latin typeface="Times New Roman" panose="02020603050405020304" pitchFamily="18" charset="0"/>
                 <a:cs typeface="Times New Roman" panose="02020603050405020304" pitchFamily="18" charset="0"/>
-              </a:rPr>
-              <a:t> é mais adequado para </a:t>
-            </a:r>
-            <a:r>
-              <a:rPr lang="pt-BR" sz="2000" b="1" dirty="0">
-                <a:solidFill>
-                  <a:srgbClr val="FF0000"/>
-                </a:solidFill>
-                <a:latin typeface="Times New Roman" panose="02020603050405020304" pitchFamily="18" charset="0"/>
-                <a:cs typeface="Times New Roman" panose="02020603050405020304" pitchFamily="18" charset="0"/>
-              </a:rPr>
-              <a:t>aplicativos complexos e de grande escala</a:t>
+                <a:hlinkClick r:id="rId4"/>
+              </a:rPr>
+              <a:t>https://spark.apache.org/documentation.html</a:t>
             </a:r>
             <a:r>
               <a:rPr lang="pt-BR" sz="2000" dirty="0">
@@ -5736,47 +5715,7 @@
                 <a:latin typeface="Times New Roman" panose="02020603050405020304" pitchFamily="18" charset="0"/>
                 <a:cs typeface="Times New Roman" panose="02020603050405020304" pitchFamily="18" charset="0"/>
               </a:rPr>
-              <a:t>, enquanto </a:t>
-            </a:r>
-            <a:r>
-              <a:rPr lang="pt-BR" sz="2000" b="1" dirty="0">
-                <a:solidFill>
-                  <a:schemeClr val="tx1"/>
-                </a:solidFill>
-                <a:latin typeface="Times New Roman" panose="02020603050405020304" pitchFamily="18" charset="0"/>
-                <a:cs typeface="Times New Roman" panose="02020603050405020304" pitchFamily="18" charset="0"/>
-              </a:rPr>
-              <a:t>Python</a:t>
-            </a:r>
-            <a:r>
-              <a:rPr lang="pt-BR" sz="2000" dirty="0">
-                <a:solidFill>
-                  <a:schemeClr val="tx1"/>
-                </a:solidFill>
-                <a:latin typeface="Times New Roman" panose="02020603050405020304" pitchFamily="18" charset="0"/>
-                <a:cs typeface="Times New Roman" panose="02020603050405020304" pitchFamily="18" charset="0"/>
-              </a:rPr>
-              <a:t> é melhor para </a:t>
-            </a:r>
-            <a:r>
-              <a:rPr lang="pt-BR" sz="2000" b="1" dirty="0">
-                <a:solidFill>
-                  <a:srgbClr val="FF0000"/>
-                </a:solidFill>
-                <a:latin typeface="Times New Roman" panose="02020603050405020304" pitchFamily="18" charset="0"/>
-                <a:cs typeface="Times New Roman" panose="02020603050405020304" pitchFamily="18" charset="0"/>
-              </a:rPr>
-              <a:t>análise de dados, computação científica e aprendizado de máquina</a:t>
-            </a:r>
-            <a:r>
-              <a:rPr lang="pt-BR" sz="2000" dirty="0">
-                <a:solidFill>
-                  <a:schemeClr val="tx1"/>
-                </a:solidFill>
-                <a:latin typeface="Times New Roman" panose="02020603050405020304" pitchFamily="18" charset="0"/>
-                <a:cs typeface="Times New Roman" panose="02020603050405020304" pitchFamily="18" charset="0"/>
-              </a:rPr>
-              <a:t>.</a:t>
+              <a:t> </a:t>
             </a:r>
           </a:p>
           <a:p>
@@ -5796,14 +5735,121 @@
               <a:buNone/>
             </a:pPr>
             <a:r>
-              <a:rPr lang="pt-BR" sz="2000" dirty="0">
+              <a:rPr lang="pt-BR" sz="2000" b="1" dirty="0">
                 <a:solidFill>
                   <a:schemeClr val="tx1"/>
                 </a:solidFill>
                 <a:latin typeface="Times New Roman" panose="02020603050405020304" pitchFamily="18" charset="0"/>
                 <a:cs typeface="Times New Roman" panose="02020603050405020304" pitchFamily="18" charset="0"/>
               </a:rPr>
-              <a:t>A estrutura do </a:t>
+              <a:t>	Java</a:t>
+            </a:r>
+            <a:r>
+              <a:rPr lang="pt-BR" sz="2000" dirty="0">
+                <a:solidFill>
+                  <a:schemeClr val="tx1"/>
+                </a:solidFill>
+                <a:latin typeface="Times New Roman" panose="02020603050405020304" pitchFamily="18" charset="0"/>
+                <a:cs typeface="Times New Roman" panose="02020603050405020304" pitchFamily="18" charset="0"/>
+              </a:rPr>
+              <a:t> é mais adequado para </a:t>
+            </a:r>
+            <a:r>
+              <a:rPr lang="pt-BR" sz="2000" b="1" dirty="0">
+                <a:solidFill>
+                  <a:srgbClr val="FF0000"/>
+                </a:solidFill>
+                <a:latin typeface="Times New Roman" panose="02020603050405020304" pitchFamily="18" charset="0"/>
+                <a:cs typeface="Times New Roman" panose="02020603050405020304" pitchFamily="18" charset="0"/>
+              </a:rPr>
+              <a:t>apps complexos e de grande escala</a:t>
+            </a:r>
+            <a:r>
+              <a:rPr lang="pt-BR" sz="2000" dirty="0">
+                <a:solidFill>
+                  <a:schemeClr val="tx1"/>
+                </a:solidFill>
+                <a:latin typeface="Times New Roman" panose="02020603050405020304" pitchFamily="18" charset="0"/>
+                <a:cs typeface="Times New Roman" panose="02020603050405020304" pitchFamily="18" charset="0"/>
+              </a:rPr>
+              <a:t>, enquanto </a:t>
+            </a:r>
+            <a:r>
+              <a:rPr lang="pt-BR" sz="2000" b="1" dirty="0">
+                <a:solidFill>
+                  <a:schemeClr val="tx1"/>
+                </a:solidFill>
+                <a:latin typeface="Times New Roman" panose="02020603050405020304" pitchFamily="18" charset="0"/>
+                <a:cs typeface="Times New Roman" panose="02020603050405020304" pitchFamily="18" charset="0"/>
+              </a:rPr>
+              <a:t>Python</a:t>
+            </a:r>
+            <a:r>
+              <a:rPr lang="pt-BR" sz="2000" dirty="0">
+                <a:solidFill>
+                  <a:schemeClr val="tx1"/>
+                </a:solidFill>
+                <a:latin typeface="Times New Roman" panose="02020603050405020304" pitchFamily="18" charset="0"/>
+                <a:cs typeface="Times New Roman" panose="02020603050405020304" pitchFamily="18" charset="0"/>
+              </a:rPr>
+              <a:t> é melhor para </a:t>
+            </a:r>
+            <a:r>
+              <a:rPr lang="pt-BR" sz="2000" b="1" dirty="0">
+                <a:solidFill>
+                  <a:srgbClr val="002060"/>
+                </a:solidFill>
+                <a:latin typeface="Times New Roman" panose="02020603050405020304" pitchFamily="18" charset="0"/>
+                <a:cs typeface="Times New Roman" panose="02020603050405020304" pitchFamily="18" charset="0"/>
+              </a:rPr>
+              <a:t>análise de dados</a:t>
+            </a:r>
+            <a:r>
+              <a:rPr lang="pt-BR" sz="2000" b="1" dirty="0">
+                <a:solidFill>
+                  <a:srgbClr val="FF0000"/>
+                </a:solidFill>
+                <a:latin typeface="Times New Roman" panose="02020603050405020304" pitchFamily="18" charset="0"/>
+                <a:cs typeface="Times New Roman" panose="02020603050405020304" pitchFamily="18" charset="0"/>
+              </a:rPr>
+              <a:t>, computação científica e </a:t>
+            </a:r>
+            <a:r>
+              <a:rPr lang="pt-BR" sz="2000" b="1" dirty="0">
+                <a:solidFill>
+                  <a:srgbClr val="002060"/>
+                </a:solidFill>
+                <a:latin typeface="Times New Roman" panose="02020603050405020304" pitchFamily="18" charset="0"/>
+                <a:cs typeface="Times New Roman" panose="02020603050405020304" pitchFamily="18" charset="0"/>
+              </a:rPr>
+              <a:t>machine learning.</a:t>
+            </a:r>
+          </a:p>
+          <a:p>
+            <a:pPr marL="0" indent="0" algn="just">
+              <a:buNone/>
+            </a:pPr>
+            <a:endParaRPr lang="pt-BR" sz="2000" dirty="0">
+              <a:solidFill>
+                <a:schemeClr val="tx1"/>
+              </a:solidFill>
+              <a:latin typeface="Times New Roman" panose="02020603050405020304" pitchFamily="18" charset="0"/>
+              <a:cs typeface="Times New Roman" panose="02020603050405020304" pitchFamily="18" charset="0"/>
+            </a:endParaRPr>
+          </a:p>
+          <a:p>
+            <a:pPr marL="0" indent="0" algn="just">
+              <a:buNone/>
+            </a:pPr>
+            <a:r>
+              <a:rPr lang="pt-BR" sz="2000" dirty="0">
+                <a:solidFill>
+                  <a:schemeClr val="tx1"/>
+                </a:solidFill>
+                <a:latin typeface="Times New Roman" panose="02020603050405020304" pitchFamily="18" charset="0"/>
+                <a:cs typeface="Times New Roman" panose="02020603050405020304" pitchFamily="18" charset="0"/>
+              </a:rPr>
+              <a:t>	A estrutura do </a:t>
             </a:r>
             <a:r>
               <a:rPr lang="pt-BR" sz="2000" b="1" dirty="0" err="1">
@@ -5833,7 +5879,7 @@
                 <a:latin typeface="Times New Roman" panose="02020603050405020304" pitchFamily="18" charset="0"/>
                 <a:cs typeface="Times New Roman" panose="02020603050405020304" pitchFamily="18" charset="0"/>
               </a:rPr>
-              <a:t>linguagem Java</a:t>
+              <a:t>Java</a:t>
             </a:r>
             <a:r>
               <a:rPr lang="pt-BR" sz="2000" dirty="0">
@@ -5947,7 +5993,7 @@
                 </a:solidFill>
                 <a:latin typeface="Times New Roman" panose="02020603050405020304" pitchFamily="18" charset="0"/>
                 <a:cs typeface="Times New Roman" panose="02020603050405020304" pitchFamily="18" charset="0"/>
-                <a:hlinkClick r:id="rId4"/>
+                <a:hlinkClick r:id="rId5"/>
               </a:rPr>
               <a:t>https://insights.stackoverflow.com/survey/2021#most-popular-technologies-language</a:t>
             </a:r>
@@ -6059,7 +6105,17 @@
               <a:buNone/>
             </a:pPr>
             <a:r>
+              <a:rPr lang="pt-BR" sz="2000" b="1" dirty="0">
+                <a:latin typeface="Times New Roman" panose="02020603050405020304" pitchFamily="18" charset="0"/>
+                <a:cs typeface="Times New Roman" panose="02020603050405020304" pitchFamily="18" charset="0"/>
+              </a:rPr>
+              <a:t>	</a:t>
+            </a:r>
+            <a:r>
               <a:rPr lang="pt-BR" sz="2000" b="1" dirty="0" err="1">
+                <a:solidFill>
+                  <a:srgbClr val="FF0000"/>
+                </a:solidFill>
                 <a:latin typeface="Times New Roman" panose="02020603050405020304" pitchFamily="18" charset="0"/>
                 <a:cs typeface="Times New Roman" panose="02020603050405020304" pitchFamily="18" charset="0"/>
               </a:rPr>
@@ -6615,7 +6671,7 @@
                 <a:latin typeface="Times New Roman" panose="02020603050405020304" pitchFamily="18" charset="0"/>
                 <a:cs typeface="Times New Roman" panose="02020603050405020304" pitchFamily="18" charset="0"/>
               </a:rPr>
-              <a:t>Hoje em dia, o </a:t>
+              <a:t>	Atualmente, o </a:t>
             </a:r>
             <a:r>
               <a:rPr lang="pt-BR" sz="2000" b="1" dirty="0">
@@ -6650,7 +6706,7 @@
                 <a:latin typeface="Times New Roman" panose="02020603050405020304" pitchFamily="18" charset="0"/>
                 <a:cs typeface="Times New Roman" panose="02020603050405020304" pitchFamily="18" charset="0"/>
               </a:rPr>
-              <a:t>Dados</a:t>
+              <a:t>	Dados</a:t>
             </a:r>
             <a:r>
               <a:rPr lang="pt-BR" sz="2000" dirty="0">
@@ -6661,6 +6717,9 @@
             </a:r>
             <a:r>
               <a:rPr lang="pt-BR" sz="2000" b="1" dirty="0">
+                <a:solidFill>
+                  <a:srgbClr val="FF0000"/>
+                </a:solidFill>
                 <a:latin typeface="Times New Roman" panose="02020603050405020304" pitchFamily="18" charset="0"/>
                 <a:cs typeface="Times New Roman" panose="02020603050405020304" pitchFamily="18" charset="0"/>
               </a:rPr>
@@ -6671,7 +6730,21 @@
                 <a:latin typeface="Times New Roman" panose="02020603050405020304" pitchFamily="18" charset="0"/>
                 <a:cs typeface="Times New Roman" panose="02020603050405020304" pitchFamily="18" charset="0"/>
               </a:rPr>
-              <a:t> (sobre vagas abertas) e ao </a:t>
+              <a:t> (</a:t>
+            </a:r>
+            <a:r>
+              <a:rPr lang="pt-BR" sz="2000" b="1" dirty="0">
+                <a:latin typeface="Times New Roman" panose="02020603050405020304" pitchFamily="18" charset="0"/>
+                <a:cs typeface="Times New Roman" panose="02020603050405020304" pitchFamily="18" charset="0"/>
+              </a:rPr>
+              <a:t>sobre vagas abertas</a:t>
+            </a:r>
+            <a:r>
+              <a:rPr lang="pt-BR" sz="2000" dirty="0">
+                <a:latin typeface="Times New Roman" panose="02020603050405020304" pitchFamily="18" charset="0"/>
+                <a:cs typeface="Times New Roman" panose="02020603050405020304" pitchFamily="18" charset="0"/>
+              </a:rPr>
+              <a:t>) e ao </a:t>
             </a:r>
             <a:r>
               <a:rPr lang="pt-BR" sz="2000" b="1" dirty="0" err="1">
@@ -6685,7 +6758,21 @@
                 <a:latin typeface="Times New Roman" panose="02020603050405020304" pitchFamily="18" charset="0"/>
                 <a:cs typeface="Times New Roman" panose="02020603050405020304" pitchFamily="18" charset="0"/>
               </a:rPr>
-              <a:t> (sobre as faixas salariais) a respeito da categoria.</a:t>
+              <a:t> (</a:t>
+            </a:r>
+            <a:r>
+              <a:rPr lang="pt-BR" sz="2000" b="1" dirty="0">
+                <a:latin typeface="Times New Roman" panose="02020603050405020304" pitchFamily="18" charset="0"/>
+                <a:cs typeface="Times New Roman" panose="02020603050405020304" pitchFamily="18" charset="0"/>
+              </a:rPr>
+              <a:t>sobre as faixas salariais</a:t>
+            </a:r>
+            <a:r>
+              <a:rPr lang="pt-BR" sz="2000" dirty="0">
+                <a:latin typeface="Times New Roman" panose="02020603050405020304" pitchFamily="18" charset="0"/>
+                <a:cs typeface="Times New Roman" panose="02020603050405020304" pitchFamily="18" charset="0"/>
+              </a:rPr>
+              <a:t>) a respeito da categoria.</a:t>
             </a:r>
           </a:p>
           <a:p>
@@ -6727,7 +6814,7 @@
                 <a:latin typeface="Times New Roman" panose="02020603050405020304" pitchFamily="18" charset="0"/>
                 <a:cs typeface="Times New Roman" panose="02020603050405020304" pitchFamily="18" charset="0"/>
               </a:rPr>
-              <a:t>: SM de R$ 6.142,00 e média de 3.613 vagas, sendo 1.087 remotas. </a:t>
+              <a:t>: R$ 6.142,00 e média de 3.613 vagas, sendo 1.087 remotas. </a:t>
             </a:r>
           </a:p>
           <a:p>
@@ -6760,7 +6847,7 @@
                 <a:latin typeface="Times New Roman" panose="02020603050405020304" pitchFamily="18" charset="0"/>
                 <a:cs typeface="Times New Roman" panose="02020603050405020304" pitchFamily="18" charset="0"/>
               </a:rPr>
-              <a:t>: SM de R$ 7.210,00 e média de 2.976 vagas, sendo 890 remotas; </a:t>
+              <a:t>: R$ 7.210,00 e média de 2.976 vagas, sendo 890 remotas; </a:t>
             </a:r>
           </a:p>
           <a:p>
@@ -6793,7 +6880,7 @@
                 <a:latin typeface="Times New Roman" panose="02020603050405020304" pitchFamily="18" charset="0"/>
                 <a:cs typeface="Times New Roman" panose="02020603050405020304" pitchFamily="18" charset="0"/>
               </a:rPr>
-              <a:t>: SM de R$ 7.601,00 e média de 2.709 vagas, sendo 946 remotas; </a:t>
+              <a:t>: R$ 7.601,00 e média de 2.709 vagas, sendo 946 remotas.</a:t>
             </a:r>
             <a:endParaRPr lang="pt-BR" sz="2000" dirty="0">
               <a:solidFill>
@@ -9136,7 +9223,7 @@
                 <a:latin typeface="Times New Roman" panose="02020603050405020304" pitchFamily="18" charset="0"/>
                 <a:cs typeface="Times New Roman" panose="02020603050405020304" pitchFamily="18" charset="0"/>
               </a:rPr>
-              <a:t># padrão eh “,”, mas pode ser diferente, talvez necessário informar o encode</a:t>
+              <a:t># padrão eh ",", mas pode ser diferente, talvez necessário informar o encode</a:t>
             </a:r>
           </a:p>
           <a:p>
@@ -9176,7 +9263,7 @@
                 <a:latin typeface="Times New Roman" panose="02020603050405020304" pitchFamily="18" charset="0"/>
                 <a:cs typeface="Times New Roman" panose="02020603050405020304" pitchFamily="18" charset="0"/>
               </a:rPr>
-              <a:t>(‘</a:t>
+              <a:t>('</a:t>
             </a:r>
             <a:r>
               <a:rPr lang="pt-BR" sz="1800" dirty="0" err="1">
@@ -9186,11 +9273,21 @@
               <a:t>sample_data</a:t>
             </a:r>
             <a:r>
+              <a:rPr lang="pt-BR" sz="1800" b="1" dirty="0">
+                <a:solidFill>
+                  <a:srgbClr val="FF0000"/>
+                </a:solidFill>
+                <a:latin typeface="Times New Roman" panose="02020603050405020304" pitchFamily="18" charset="0"/>
+                <a:cs typeface="Times New Roman" panose="02020603050405020304" pitchFamily="18" charset="0"/>
+              </a:rPr>
+              <a:t>/???.csv</a:t>
+            </a:r>
+            <a:r>
               <a:rPr lang="pt-BR" sz="1800" dirty="0">
                 <a:latin typeface="Times New Roman" panose="02020603050405020304" pitchFamily="18" charset="0"/>
                 <a:cs typeface="Times New Roman" panose="02020603050405020304" pitchFamily="18" charset="0"/>
               </a:rPr>
-              <a:t>/arq.csv’, </a:t>
+              <a:t>', </a:t>
             </a:r>
             <a:r>
               <a:rPr lang="pt-BR" sz="1800" dirty="0" err="1">
@@ -9204,7 +9301,7 @@
                 <a:latin typeface="Times New Roman" panose="02020603050405020304" pitchFamily="18" charset="0"/>
                 <a:cs typeface="Times New Roman" panose="02020603050405020304" pitchFamily="18" charset="0"/>
               </a:rPr>
-              <a:t>=‘;’, </a:t>
+              <a:t>=';', </a:t>
             </a:r>
             <a:r>
               <a:rPr lang="pt-BR" sz="1800" dirty="0" err="1">
@@ -9218,8 +9315,35 @@
                 <a:latin typeface="Times New Roman" panose="02020603050405020304" pitchFamily="18" charset="0"/>
                 <a:cs typeface="Times New Roman" panose="02020603050405020304" pitchFamily="18" charset="0"/>
               </a:rPr>
-              <a:t>=‘cp1252’)</a:t>
-            </a:r>
+              <a:t>='cp1252’) # </a:t>
+            </a:r>
+            <a:r>
+              <a:rPr lang="pt-BR" sz="1800" b="1" dirty="0">
+                <a:solidFill>
+                  <a:srgbClr val="FF0000"/>
+                </a:solidFill>
+                <a:latin typeface="Times New Roman" panose="02020603050405020304" pitchFamily="18" charset="0"/>
+                <a:cs typeface="Times New Roman" panose="02020603050405020304" pitchFamily="18" charset="0"/>
+              </a:rPr>
+              <a:t>escolher um </a:t>
+            </a:r>
+            <a:r>
+              <a:rPr lang="pt-BR" sz="1800" b="1" dirty="0" err="1">
+                <a:solidFill>
+                  <a:srgbClr val="FF0000"/>
+                </a:solidFill>
+                <a:latin typeface="Times New Roman" panose="02020603050405020304" pitchFamily="18" charset="0"/>
+                <a:cs typeface="Times New Roman" panose="02020603050405020304" pitchFamily="18" charset="0"/>
+              </a:rPr>
+              <a:t>aqruivo</a:t>
+            </a:r>
+            <a:endParaRPr lang="pt-BR" sz="1800" b="1" dirty="0">
+              <a:solidFill>
+                <a:srgbClr val="FF0000"/>
+              </a:solidFill>
+              <a:latin typeface="Times New Roman" panose="02020603050405020304" pitchFamily="18" charset="0"/>
+              <a:cs typeface="Times New Roman" panose="02020603050405020304" pitchFamily="18" charset="0"/>
+            </a:endParaRPr>
           </a:p>
           <a:p>
             <a:pPr marL="0" indent="0" algn="just">
@@ -9298,6 +9422,20 @@
                 <a:latin typeface="Times New Roman" panose="02020603050405020304" pitchFamily="18" charset="0"/>
                 <a:cs typeface="Times New Roman" panose="02020603050405020304" pitchFamily="18" charset="0"/>
               </a:rPr>
+              <a:t>printf</a:t>
+            </a:r>
+            <a:r>
+              <a:rPr lang="pt-BR" sz="1800" b="1" dirty="0">
+                <a:latin typeface="Times New Roman" panose="02020603050405020304" pitchFamily="18" charset="0"/>
+                <a:cs typeface="Times New Roman" panose="02020603050405020304" pitchFamily="18" charset="0"/>
+              </a:rPr>
+              <a:t>(</a:t>
+            </a:r>
+            <a:r>
+              <a:rPr lang="pt-BR" sz="1800" dirty="0" err="1">
+                <a:latin typeface="Times New Roman" panose="02020603050405020304" pitchFamily="18" charset="0"/>
+                <a:cs typeface="Times New Roman" panose="02020603050405020304" pitchFamily="18" charset="0"/>
+              </a:rPr>
               <a:t>df.c</a:t>
             </a:r>
             <a:r>
@@ -9312,7 +9450,7 @@
                 <a:latin typeface="Times New Roman" panose="02020603050405020304" pitchFamily="18" charset="0"/>
                 <a:cs typeface="Times New Roman" panose="02020603050405020304" pitchFamily="18" charset="0"/>
               </a:rPr>
-              <a:t>()</a:t>
+              <a:t>())</a:t>
             </a:r>
             <a:r>
               <a:rPr lang="pt-BR" sz="1800" dirty="0">
@@ -9574,7 +9712,7 @@
                   <a:srgbClr val="0070C0"/>
                 </a:solidFill>
               </a:rPr>
-              <a:t>Outros </a:t>
+              <a:t>Link para </a:t>
             </a:r>
             <a:r>
               <a:rPr lang="en-US" b="1" dirty="0" err="1">
@@ -9582,23 +9720,15 @@
                   <a:srgbClr val="0070C0"/>
                 </a:solidFill>
               </a:rPr>
-              <a:t>Dinâmica</a:t>
-            </a:r>
-            <a:r>
-              <a:rPr lang="en-US" b="1" dirty="0">
+              <a:t>Estudo</a:t>
+            </a:r>
+            <a:r>
+              <a:rPr lang="en-US" b="1">
                 <a:solidFill>
                   <a:srgbClr val="0070C0"/>
                 </a:solidFill>
               </a:rPr>
-              <a:t>/</a:t>
-            </a:r>
-            <a:r>
-              <a:rPr lang="en-US" b="1" dirty="0" err="1">
-                <a:solidFill>
-                  <a:srgbClr val="0070C0"/>
-                </a:solidFill>
-              </a:rPr>
-              <a:t>Atividades</a:t>
+              <a:t> Python</a:t>
             </a:r>
             <a:endParaRPr lang="en-US" b="1" dirty="0">
               <a:solidFill>
@@ -9660,15 +9790,6 @@
             <a:pPr marL="0" indent="0" algn="just">
               <a:buNone/>
             </a:pPr>
-            <a:endParaRPr lang="pt-BR" sz="1800" dirty="0">
-              <a:latin typeface="Times New Roman" panose="02020603050405020304" pitchFamily="18" charset="0"/>
-              <a:cs typeface="Times New Roman" panose="02020603050405020304" pitchFamily="18" charset="0"/>
-            </a:endParaRPr>
-          </a:p>
-          <a:p>
-            <a:pPr marL="0" indent="0" algn="just">
-              <a:buNone/>
-            </a:pPr>
             <a:r>
               <a:rPr lang="pt-BR" sz="1800" dirty="0">
                 <a:latin typeface="Times New Roman" panose="02020603050405020304" pitchFamily="18" charset="0"/>
@@ -9677,14 +9798,14 @@
               <a:t>	</a:t>
             </a:r>
             <a:r>
-              <a:rPr lang="pt-BR" sz="1800" dirty="0">
+              <a:rPr lang="pt-BR" sz="2400" dirty="0">
                 <a:latin typeface="Times New Roman" panose="02020603050405020304" pitchFamily="18" charset="0"/>
                 <a:cs typeface="Times New Roman" panose="02020603050405020304" pitchFamily="18" charset="0"/>
                 <a:hlinkClick r:id="rId3"/>
               </a:rPr>
               <a:t>https://www.e-setorial.com.br/blog/229-170-projetos-de-data-science-e-machine-learning-com-python-resolvidos-e-explicados</a:t>
             </a:r>
-            <a:endParaRPr lang="pt-BR" sz="1800" dirty="0">
+            <a:endParaRPr lang="pt-BR" sz="2400" dirty="0">
               <a:latin typeface="Times New Roman" panose="02020603050405020304" pitchFamily="18" charset="0"/>
               <a:cs typeface="Times New Roman" panose="02020603050405020304" pitchFamily="18" charset="0"/>
             </a:endParaRPr>
@@ -10562,7 +10683,7 @@
                 <a:latin typeface="Times New Roman" panose="02020603050405020304" pitchFamily="18" charset="0"/>
                 <a:cs typeface="Times New Roman" panose="02020603050405020304" pitchFamily="18" charset="0"/>
               </a:rPr>
-              <a:t>O </a:t>
+              <a:t>	O </a:t>
             </a:r>
             <a:r>
               <a:rPr lang="pt-BR" sz="2000" b="1" dirty="0">
@@ -10628,7 +10749,7 @@
                 <a:latin typeface="Times New Roman" panose="02020603050405020304" pitchFamily="18" charset="0"/>
                 <a:cs typeface="Times New Roman" panose="02020603050405020304" pitchFamily="18" charset="0"/>
               </a:rPr>
-              <a:t>Pode trabalhar também – em termos de desenvolvimento de código – usando </a:t>
+              <a:t>	Pode trabalhar também – em termos de desenvolvimento de código – usando </a:t>
             </a:r>
             <a:r>
               <a:rPr lang="pt-BR" sz="2000" b="1" dirty="0">
@@ -10652,7 +10773,7 @@
                 <a:latin typeface="Times New Roman" panose="02020603050405020304" pitchFamily="18" charset="0"/>
                 <a:cs typeface="Times New Roman" panose="02020603050405020304" pitchFamily="18" charset="0"/>
               </a:rPr>
-              <a:t>Big Data </a:t>
+              <a:t>Big Data é </a:t>
             </a:r>
             <a:r>
               <a:rPr lang="pt-BR" sz="2000" dirty="0">
@@ -10694,7 +10815,7 @@
                 <a:latin typeface="Times New Roman" panose="02020603050405020304" pitchFamily="18" charset="0"/>
                 <a:cs typeface="Times New Roman" panose="02020603050405020304" pitchFamily="18" charset="0"/>
               </a:rPr>
-              <a:t>Esses dois aspectos estão permitindo que desenvolvedores em todo o mundo adotem o </a:t>
+              <a:t>	Esses dois aspectos estão permitindo que desenvolvedores em todo o mundo adotem o </a:t>
             </a:r>
             <a:r>
               <a:rPr lang="pt-BR" sz="2000" b="1" dirty="0">
@@ -10874,7 +10995,7 @@
                 <a:latin typeface="Times New Roman" panose="02020603050405020304" pitchFamily="18" charset="0"/>
                 <a:cs typeface="Times New Roman" panose="02020603050405020304" pitchFamily="18" charset="0"/>
               </a:rPr>
-              <a:t>Alguns desenvolvedores dizem que o </a:t>
+              <a:t>	Alguns desenvolvedores dizem que o </a:t>
             </a:r>
             <a:r>
               <a:rPr lang="pt-BR" sz="2000" b="1" dirty="0">
@@ -10912,49 +11033,42 @@
                 <a:latin typeface="Times New Roman" panose="02020603050405020304" pitchFamily="18" charset="0"/>
                 <a:cs typeface="Times New Roman" panose="02020603050405020304" pitchFamily="18" charset="0"/>
               </a:rPr>
-              <a:t>Python</a:t>
-            </a:r>
-            <a:r>
-              <a:rPr lang="pt-BR" sz="2000" dirty="0">
-                <a:latin typeface="Times New Roman" panose="02020603050405020304" pitchFamily="18" charset="0"/>
-                <a:cs typeface="Times New Roman" panose="02020603050405020304" pitchFamily="18" charset="0"/>
-              </a:rPr>
-              <a:t>, agora quando está trabalhando com grande quantidade de dados (</a:t>
+              <a:t>Python.</a:t>
+            </a:r>
+            <a:r>
+              <a:rPr lang="pt-BR" sz="2000" dirty="0">
+                <a:latin typeface="Times New Roman" panose="02020603050405020304" pitchFamily="18" charset="0"/>
+                <a:cs typeface="Times New Roman" panose="02020603050405020304" pitchFamily="18" charset="0"/>
+              </a:rPr>
+              <a:t> Agora quando está trabalhando com grande quantidade de dados (</a:t>
+            </a:r>
+            <a:r>
+              <a:rPr lang="pt-BR" sz="2000" b="1" dirty="0" err="1">
+                <a:latin typeface="Times New Roman" panose="02020603050405020304" pitchFamily="18" charset="0"/>
+                <a:cs typeface="Times New Roman" panose="02020603050405020304" pitchFamily="18" charset="0"/>
+              </a:rPr>
+              <a:t>GBs</a:t>
             </a:r>
             <a:r>
               <a:rPr lang="pt-BR" sz="2000" b="1" dirty="0">
                 <a:latin typeface="Times New Roman" panose="02020603050405020304" pitchFamily="18" charset="0"/>
                 <a:cs typeface="Times New Roman" panose="02020603050405020304" pitchFamily="18" charset="0"/>
               </a:rPr>
-              <a:t>em </a:t>
+              <a:t>, </a:t>
             </a:r>
             <a:r>
               <a:rPr lang="pt-BR" sz="2000" b="1" dirty="0" err="1">
                 <a:latin typeface="Times New Roman" panose="02020603050405020304" pitchFamily="18" charset="0"/>
                 <a:cs typeface="Times New Roman" panose="02020603050405020304" pitchFamily="18" charset="0"/>
               </a:rPr>
-              <a:t>GBs</a:t>
+              <a:t>TBs</a:t>
             </a:r>
             <a:r>
               <a:rPr lang="pt-BR" sz="2000" b="1" dirty="0">
                 <a:latin typeface="Times New Roman" panose="02020603050405020304" pitchFamily="18" charset="0"/>
                 <a:cs typeface="Times New Roman" panose="02020603050405020304" pitchFamily="18" charset="0"/>
               </a:rPr>
-              <a:t>, </a:t>
-            </a:r>
-            <a:r>
-              <a:rPr lang="pt-BR" sz="2000" b="1" dirty="0" err="1">
-                <a:latin typeface="Times New Roman" panose="02020603050405020304" pitchFamily="18" charset="0"/>
-                <a:cs typeface="Times New Roman" panose="02020603050405020304" pitchFamily="18" charset="0"/>
-              </a:rPr>
-              <a:t>TBs</a:t>
-            </a:r>
-            <a:r>
-              <a:rPr lang="pt-BR" sz="2000" b="1" dirty="0">
-                <a:latin typeface="Times New Roman" panose="02020603050405020304" pitchFamily="18" charset="0"/>
-                <a:cs typeface="Times New Roman" panose="02020603050405020304" pitchFamily="18" charset="0"/>
-              </a:rPr>
-              <a:t> e mais</a:t>
+              <a:t>, etc.</a:t>
             </a:r>
             <a:r>
               <a:rPr lang="pt-BR" sz="2000" dirty="0">
@@ -11065,7 +11179,7 @@
                 <a:latin typeface="Times New Roman" panose="02020603050405020304" pitchFamily="18" charset="0"/>
                 <a:cs typeface="Times New Roman" panose="02020603050405020304" pitchFamily="18" charset="0"/>
               </a:rPr>
-              <a:t>Pode-se </a:t>
+              <a:t>	Pode-se </a:t>
             </a:r>
             <a:r>
               <a:rPr lang="pt-BR" sz="2000" b="1" dirty="0">
@@ -11196,18 +11310,11 @@
               <a:buNone/>
             </a:pPr>
             <a:r>
-              <a:rPr lang="pt-BR" sz="2000" dirty="0">
-                <a:latin typeface="Times New Roman" panose="02020603050405020304" pitchFamily="18" charset="0"/>
-                <a:cs typeface="Times New Roman" panose="02020603050405020304" pitchFamily="18" charset="0"/>
-              </a:rPr>
-              <a:t>O </a:t>
-            </a:r>
-            <a:r>
               <a:rPr lang="pt-BR" sz="2000" b="1" dirty="0">
                 <a:latin typeface="Times New Roman" panose="02020603050405020304" pitchFamily="18" charset="0"/>
                 <a:cs typeface="Times New Roman" panose="02020603050405020304" pitchFamily="18" charset="0"/>
               </a:rPr>
-              <a:t>Python</a:t>
+              <a:t>	Python</a:t>
             </a:r>
             <a:r>
               <a:rPr lang="pt-BR" sz="2000" dirty="0">
@@ -11364,7 +11471,7 @@
                 <a:latin typeface="Times New Roman" panose="02020603050405020304" pitchFamily="18" charset="0"/>
                 <a:cs typeface="Times New Roman" panose="02020603050405020304" pitchFamily="18" charset="0"/>
               </a:rPr>
-              <a:t>Permite que se conecte a uma </a:t>
+              <a:t>	Permite que se conecte a uma </a:t>
             </a:r>
             <a:r>
               <a:rPr lang="pt-BR" sz="2000" b="1" dirty="0">
@@ -11392,35 +11499,6 @@
               </a:rPr>
               <a:t>	</a:t>
             </a:r>
-            <a:r>
-              <a:rPr lang="pt-BR" sz="2000" b="1" dirty="0">
-                <a:solidFill>
-                  <a:srgbClr val="FF0000"/>
-                </a:solidFill>
-                <a:latin typeface="Times New Roman" panose="02020603050405020304" pitchFamily="18" charset="0"/>
-                <a:cs typeface="Times New Roman" panose="02020603050405020304" pitchFamily="18" charset="0"/>
-              </a:rPr>
-              <a:t>Leia</a:t>
-            </a:r>
-            <a:r>
-              <a:rPr lang="pt-BR" sz="2000" dirty="0">
-                <a:latin typeface="Times New Roman" panose="02020603050405020304" pitchFamily="18" charset="0"/>
-                <a:cs typeface="Times New Roman" panose="02020603050405020304" pitchFamily="18" charset="0"/>
-              </a:rPr>
-              <a:t>: </a:t>
-            </a:r>
-            <a:r>
-              <a:rPr lang="pt-BR" sz="2000" dirty="0">
-                <a:latin typeface="Times New Roman" panose="02020603050405020304" pitchFamily="18" charset="0"/>
-                <a:cs typeface="Times New Roman" panose="02020603050405020304" pitchFamily="18" charset="0"/>
-                <a:hlinkClick r:id="rId3"/>
-              </a:rPr>
-              <a:t>https://www.edureka.co/microsoft-azure-data-engineering-certification-course</a:t>
-            </a:r>
-            <a:endParaRPr lang="pt-BR" sz="2000" dirty="0">
-              <a:latin typeface="Times New Roman" panose="02020603050405020304" pitchFamily="18" charset="0"/>
-              <a:cs typeface="Times New Roman" panose="02020603050405020304" pitchFamily="18" charset="0"/>
-            </a:endParaRPr>
           </a:p>
         </p:txBody>
       </p:sp>
@@ -11523,7 +11601,7 @@
                 <a:latin typeface="Times New Roman" panose="02020603050405020304" pitchFamily="18" charset="0"/>
                 <a:cs typeface="Times New Roman" panose="02020603050405020304" pitchFamily="18" charset="0"/>
               </a:rPr>
-              <a:t>A </a:t>
+              <a:t>	A </a:t>
             </a:r>
             <a:r>
               <a:rPr lang="pt-BR" sz="2000" b="1" dirty="0">
@@ -11582,7 +11660,7 @@
                 <a:latin typeface="Times New Roman" panose="02020603050405020304" pitchFamily="18" charset="0"/>
                 <a:cs typeface="Times New Roman" panose="02020603050405020304" pitchFamily="18" charset="0"/>
               </a:rPr>
-              <a:t>Conceitos avançados de </a:t>
+              <a:t>	Conceitos avançados de </a:t>
             </a:r>
             <a:r>
               <a:rPr lang="pt-BR" sz="2000" b="1" dirty="0" err="1">
@@ -11643,40 +11721,76 @@
             <a:pPr marL="0" indent="0" algn="just">
               <a:buNone/>
             </a:pPr>
-            <a:r>
-              <a:rPr lang="pt-BR" sz="2000" dirty="0">
-                <a:latin typeface="Times New Roman" panose="02020603050405020304" pitchFamily="18" charset="0"/>
-                <a:cs typeface="Times New Roman" panose="02020603050405020304" pitchFamily="18" charset="0"/>
-              </a:rPr>
-              <a:t>No exemplo abaixo, executarei um programa simples de contagem de palavras </a:t>
-            </a:r>
-            <a:r>
-              <a:rPr lang="pt-BR" sz="2000" dirty="0" err="1">
-                <a:latin typeface="Times New Roman" panose="02020603050405020304" pitchFamily="18" charset="0"/>
-                <a:cs typeface="Times New Roman" panose="02020603050405020304" pitchFamily="18" charset="0"/>
-              </a:rPr>
-              <a:t>MapReduce</a:t>
-            </a:r>
-            <a:r>
-              <a:rPr lang="pt-BR" sz="2000" dirty="0">
-                <a:latin typeface="Times New Roman" panose="02020603050405020304" pitchFamily="18" charset="0"/>
-                <a:cs typeface="Times New Roman" panose="02020603050405020304" pitchFamily="18" charset="0"/>
-              </a:rPr>
-              <a:t> escrito em Python que conta a frequência de ocorrência de uma palavra no arquivo de entrada. Portanto, temos dois arquivos abaixo – 'mapper.py' e 'reducer.py', ambos escritos em </a:t>
-            </a:r>
-            <a:r>
-              <a:rPr lang="pt-BR" sz="2000" dirty="0" err="1">
-                <a:latin typeface="Times New Roman" panose="02020603050405020304" pitchFamily="18" charset="0"/>
-                <a:cs typeface="Times New Roman" panose="02020603050405020304" pitchFamily="18" charset="0"/>
-              </a:rPr>
-              <a:t>python</a:t>
-            </a:r>
-            <a:r>
-              <a:rPr lang="pt-BR" sz="2000" dirty="0">
-                <a:latin typeface="Times New Roman" panose="02020603050405020304" pitchFamily="18" charset="0"/>
-                <a:cs typeface="Times New Roman" panose="02020603050405020304" pitchFamily="18" charset="0"/>
-              </a:rPr>
-              <a:t>.</a:t>
+            <a:endParaRPr lang="pt-BR" sz="2000" dirty="0">
+              <a:latin typeface="Times New Roman" panose="02020603050405020304" pitchFamily="18" charset="0"/>
+              <a:cs typeface="Times New Roman" panose="02020603050405020304" pitchFamily="18" charset="0"/>
+            </a:endParaRPr>
+          </a:p>
+          <a:p>
+            <a:pPr marL="0" indent="0" algn="just">
+              <a:buNone/>
+            </a:pPr>
+            <a:r>
+              <a:rPr lang="pt-BR" sz="2000" b="1" dirty="0">
+                <a:solidFill>
+                  <a:srgbClr val="FF0000"/>
+                </a:solidFill>
+                <a:latin typeface="Times New Roman" panose="02020603050405020304" pitchFamily="18" charset="0"/>
+                <a:cs typeface="Times New Roman" panose="02020603050405020304" pitchFamily="18" charset="0"/>
+              </a:rPr>
+              <a:t>Certificações</a:t>
+            </a:r>
+            <a:r>
+              <a:rPr lang="pt-BR" sz="2000" dirty="0">
+                <a:latin typeface="Times New Roman" panose="02020603050405020304" pitchFamily="18" charset="0"/>
+                <a:cs typeface="Times New Roman" panose="02020603050405020304" pitchFamily="18" charset="0"/>
+              </a:rPr>
+              <a:t>:</a:t>
+            </a:r>
+          </a:p>
+          <a:p>
+            <a:pPr marL="0" indent="0" algn="just">
+              <a:buNone/>
+            </a:pPr>
+            <a:r>
+              <a:rPr lang="pt-BR" sz="2000" dirty="0">
+                <a:latin typeface="Times New Roman" panose="02020603050405020304" pitchFamily="18" charset="0"/>
+                <a:cs typeface="Times New Roman" panose="02020603050405020304" pitchFamily="18" charset="0"/>
+              </a:rPr>
+              <a:t>     </a:t>
+            </a:r>
+            <a:r>
+              <a:rPr lang="pt-BR" sz="2000" dirty="0">
+                <a:latin typeface="Times New Roman" panose="02020603050405020304" pitchFamily="18" charset="0"/>
+                <a:cs typeface="Times New Roman" panose="02020603050405020304" pitchFamily="18" charset="0"/>
+                <a:hlinkClick r:id="rId3"/>
+              </a:rPr>
+              <a:t>https://www.edureka.co/microsoft-azure-data-engineering-certification-course</a:t>
+            </a:r>
+            <a:endParaRPr lang="pt-BR" sz="2000" dirty="0">
+              <a:latin typeface="Times New Roman" panose="02020603050405020304" pitchFamily="18" charset="0"/>
+              <a:cs typeface="Times New Roman" panose="02020603050405020304" pitchFamily="18" charset="0"/>
+            </a:endParaRPr>
+          </a:p>
+          <a:p>
+            <a:pPr marL="0" indent="0" algn="just">
+              <a:buNone/>
+            </a:pPr>
+            <a:endParaRPr lang="pt-BR" sz="2000" dirty="0">
+              <a:latin typeface="Times New Roman" panose="02020603050405020304" pitchFamily="18" charset="0"/>
+              <a:cs typeface="Times New Roman" panose="02020603050405020304" pitchFamily="18" charset="0"/>
+            </a:endParaRPr>
+          </a:p>
+          <a:p>
+            <a:pPr marL="0" indent="0" algn="just">
+              <a:buNone/>
+            </a:pPr>
+            <a:r>
+              <a:rPr lang="pt-BR" sz="2000" dirty="0">
+                <a:latin typeface="Times New Roman" panose="02020603050405020304" pitchFamily="18" charset="0"/>
+                <a:cs typeface="Times New Roman" panose="02020603050405020304" pitchFamily="18" charset="0"/>
+              </a:rPr>
+              <a:t>	</a:t>
             </a:r>
           </a:p>
         </p:txBody>
@@ -11809,7 +11923,10 @@
               <a:buChar char="§"/>
             </a:pPr>
             <a:r>
-              <a:rPr lang="pt-BR" sz="2000" dirty="0">
+              <a:rPr lang="pt-BR" sz="2000" b="1" dirty="0">
+                <a:solidFill>
+                  <a:srgbClr val="FF0000"/>
+                </a:solidFill>
                 <a:latin typeface="Times New Roman" panose="02020603050405020304" pitchFamily="18" charset="0"/>
                 <a:cs typeface="Times New Roman" panose="02020603050405020304" pitchFamily="18" charset="0"/>
               </a:rPr>
@@ -11964,7 +12081,24 @@
                 <a:latin typeface="Times New Roman" panose="02020603050405020304" pitchFamily="18" charset="0"/>
                 <a:cs typeface="Times New Roman" panose="02020603050405020304" pitchFamily="18" charset="0"/>
               </a:rPr>
-              <a:t>Entender como um Engenheiro de Big Data aplica as tecnologias para resolução de problemas relacionados à dados;</a:t>
+              <a:t>Entender como um </a:t>
+            </a:r>
+            <a:r>
+              <a:rPr lang="pt-BR" sz="2000" b="1" dirty="0">
+                <a:solidFill>
+                  <a:srgbClr val="FF0000"/>
+                </a:solidFill>
+                <a:latin typeface="Times New Roman" panose="02020603050405020304" pitchFamily="18" charset="0"/>
+                <a:cs typeface="Times New Roman" panose="02020603050405020304" pitchFamily="18" charset="0"/>
+              </a:rPr>
+              <a:t>Engenheiro de Big Data </a:t>
+            </a:r>
+            <a:r>
+              <a:rPr lang="pt-BR" sz="2000" dirty="0">
+                <a:latin typeface="Times New Roman" panose="02020603050405020304" pitchFamily="18" charset="0"/>
+                <a:cs typeface="Times New Roman" panose="02020603050405020304" pitchFamily="18" charset="0"/>
+              </a:rPr>
+              <a:t>aplica as tecnologias para resolução de problemas relacionados à dados;</a:t>
             </a:r>
           </a:p>
           <a:p>
@@ -11987,7 +12121,24 @@
                 <a:latin typeface="Times New Roman" panose="02020603050405020304" pitchFamily="18" charset="0"/>
                 <a:cs typeface="Times New Roman" panose="02020603050405020304" pitchFamily="18" charset="0"/>
               </a:rPr>
-              <a:t>Extrair e carregar tabelas a partir de arquivos, bases de dados e outras fontes (ETL);</a:t>
+              <a:t>Extrair e carregar tabelas a partir de arquivos, bases de dados e outras fontes (</a:t>
+            </a:r>
+            <a:r>
+              <a:rPr lang="pt-BR" sz="2000" b="1" dirty="0">
+                <a:solidFill>
+                  <a:srgbClr val="FF0000"/>
+                </a:solidFill>
+                <a:latin typeface="Times New Roman" panose="02020603050405020304" pitchFamily="18" charset="0"/>
+                <a:cs typeface="Times New Roman" panose="02020603050405020304" pitchFamily="18" charset="0"/>
+              </a:rPr>
+              <a:t>ETL</a:t>
+            </a:r>
+            <a:r>
+              <a:rPr lang="pt-BR" sz="2000" dirty="0">
+                <a:latin typeface="Times New Roman" panose="02020603050405020304" pitchFamily="18" charset="0"/>
+                <a:cs typeface="Times New Roman" panose="02020603050405020304" pitchFamily="18" charset="0"/>
+              </a:rPr>
+              <a:t>);</a:t>
             </a:r>
           </a:p>
           <a:p>
@@ -12033,7 +12184,24 @@
                 <a:latin typeface="Times New Roman" panose="02020603050405020304" pitchFamily="18" charset="0"/>
                 <a:cs typeface="Times New Roman" panose="02020603050405020304" pitchFamily="18" charset="0"/>
               </a:rPr>
-              <a:t>Planejar e implementar um projeto de Big Data para Análise e Visualização de Dados.</a:t>
+              <a:t>Planejar e implementar um projeto de </a:t>
+            </a:r>
+            <a:r>
+              <a:rPr lang="pt-BR" sz="2000" b="1" dirty="0">
+                <a:solidFill>
+                  <a:srgbClr val="FF0000"/>
+                </a:solidFill>
+                <a:latin typeface="Times New Roman" panose="02020603050405020304" pitchFamily="18" charset="0"/>
+                <a:cs typeface="Times New Roman" panose="02020603050405020304" pitchFamily="18" charset="0"/>
+              </a:rPr>
+              <a:t>Big Data </a:t>
+            </a:r>
+            <a:r>
+              <a:rPr lang="pt-BR" sz="2000" dirty="0">
+                <a:latin typeface="Times New Roman" panose="02020603050405020304" pitchFamily="18" charset="0"/>
+                <a:cs typeface="Times New Roman" panose="02020603050405020304" pitchFamily="18" charset="0"/>
+              </a:rPr>
+              <a:t>para Análise e Visualização de Dados.</a:t>
             </a:r>
             <a:endParaRPr lang="pt-BR" sz="2000" dirty="0">
               <a:solidFill>
@@ -12144,7 +12312,7 @@
                 <a:latin typeface="Times New Roman" panose="02020603050405020304" pitchFamily="18" charset="0"/>
                 <a:cs typeface="Times New Roman" panose="02020603050405020304" pitchFamily="18" charset="0"/>
               </a:rPr>
-              <a:t>As tarefas diárias de um cientista de dados envolvem muitas </a:t>
+              <a:t>	As tarefas diárias de um cientista de dados envolvem muitas </a:t>
             </a:r>
             <a:r>
               <a:rPr lang="pt-BR" sz="2000" b="1" dirty="0">
@@ -12275,7 +12443,7 @@
                 <a:latin typeface="Times New Roman" panose="02020603050405020304" pitchFamily="18" charset="0"/>
                 <a:cs typeface="Times New Roman" panose="02020603050405020304" pitchFamily="18" charset="0"/>
               </a:rPr>
-              <a:t>As </a:t>
+              <a:t>	As </a:t>
             </a:r>
             <a:r>
               <a:rPr lang="pt-BR" sz="2000" b="1" dirty="0">
@@ -12341,7 +12509,7 @@
                 <a:latin typeface="Times New Roman" panose="02020603050405020304" pitchFamily="18" charset="0"/>
                 <a:cs typeface="Times New Roman" panose="02020603050405020304" pitchFamily="18" charset="0"/>
               </a:rPr>
-              <a:t>Python</a:t>
+              <a:t>	Python</a:t>
             </a:r>
             <a:r>
               <a:rPr lang="pt-BR" sz="2000" dirty="0">

</xml_diff>

<commit_message>
Big Data IoT Python UniRuy Wyden Google COLAB....
</commit_message>
<xml_diff>
--- a/01 Classes/Aula 10 - Aplicação Cloud Indústria 40 Python Integração Cloud Big Data Parte 1.pptx
+++ b/01 Classes/Aula 10 - Aplicação Cloud Indústria 40 Python Integração Cloud Big Data Parte 1.pptx
@@ -9263,31 +9263,35 @@
                 <a:latin typeface="Times New Roman" panose="02020603050405020304" pitchFamily="18" charset="0"/>
                 <a:cs typeface="Times New Roman" panose="02020603050405020304" pitchFamily="18" charset="0"/>
               </a:rPr>
-              <a:t>('</a:t>
+              <a:t>('/</a:t>
             </a:r>
             <a:r>
               <a:rPr lang="pt-BR" sz="1800" dirty="0" err="1">
                 <a:latin typeface="Times New Roman" panose="02020603050405020304" pitchFamily="18" charset="0"/>
                 <a:cs typeface="Times New Roman" panose="02020603050405020304" pitchFamily="18" charset="0"/>
               </a:rPr>
+              <a:t>content</a:t>
+            </a:r>
+            <a:r>
+              <a:rPr lang="pt-BR" sz="1800" dirty="0">
+                <a:latin typeface="Times New Roman" panose="02020603050405020304" pitchFamily="18" charset="0"/>
+                <a:cs typeface="Times New Roman" panose="02020603050405020304" pitchFamily="18" charset="0"/>
+              </a:rPr>
+              <a:t>/</a:t>
+            </a:r>
+            <a:r>
+              <a:rPr lang="pt-BR" sz="1800" dirty="0" err="1">
+                <a:latin typeface="Times New Roman" panose="02020603050405020304" pitchFamily="18" charset="0"/>
+                <a:cs typeface="Times New Roman" panose="02020603050405020304" pitchFamily="18" charset="0"/>
+              </a:rPr>
               <a:t>sample_data</a:t>
             </a:r>
             <a:r>
-              <a:rPr lang="pt-BR" sz="1800" b="1" dirty="0">
-                <a:solidFill>
-                  <a:srgbClr val="FF0000"/>
-                </a:solidFill>
-                <a:latin typeface="Times New Roman" panose="02020603050405020304" pitchFamily="18" charset="0"/>
-                <a:cs typeface="Times New Roman" panose="02020603050405020304" pitchFamily="18" charset="0"/>
-              </a:rPr>
-              <a:t>/???.csv</a:t>
-            </a:r>
-            <a:r>
               <a:rPr lang="pt-BR" sz="1800" dirty="0">
                 <a:latin typeface="Times New Roman" panose="02020603050405020304" pitchFamily="18" charset="0"/>
                 <a:cs typeface="Times New Roman" panose="02020603050405020304" pitchFamily="18" charset="0"/>
               </a:rPr>
-              <a:t>', </a:t>
+              <a:t>/california_housing_train.csv', </a:t>
             </a:r>
             <a:r>
               <a:rPr lang="pt-BR" sz="1800" dirty="0" err="1">
@@ -9301,7 +9305,7 @@
                 <a:latin typeface="Times New Roman" panose="02020603050405020304" pitchFamily="18" charset="0"/>
                 <a:cs typeface="Times New Roman" panose="02020603050405020304" pitchFamily="18" charset="0"/>
               </a:rPr>
-              <a:t>=';', </a:t>
+              <a:t>=',', </a:t>
             </a:r>
             <a:r>
               <a:rPr lang="pt-BR" sz="1800" dirty="0" err="1">
@@ -9315,7 +9319,7 @@
                 <a:latin typeface="Times New Roman" panose="02020603050405020304" pitchFamily="18" charset="0"/>
                 <a:cs typeface="Times New Roman" panose="02020603050405020304" pitchFamily="18" charset="0"/>
               </a:rPr>
-              <a:t>='cp1252’) # </a:t>
+              <a:t>='cp1252') # </a:t>
             </a:r>
             <a:r>
               <a:rPr lang="pt-BR" sz="1800" b="1" dirty="0">
@@ -9368,7 +9372,21 @@
                 <a:latin typeface="Times New Roman" panose="02020603050405020304" pitchFamily="18" charset="0"/>
                 <a:cs typeface="Times New Roman" panose="02020603050405020304" pitchFamily="18" charset="0"/>
               </a:rPr>
-              <a:t>() # 5 primeiras linhas do </a:t>
+              <a:t>() # 5 </a:t>
+            </a:r>
+            <a:r>
+              <a:rPr lang="pt-BR" sz="1800" b="1" dirty="0" err="1">
+                <a:latin typeface="Times New Roman" panose="02020603050405020304" pitchFamily="18" charset="0"/>
+                <a:cs typeface="Times New Roman" panose="02020603050405020304" pitchFamily="18" charset="0"/>
+              </a:rPr>
+              <a:t>head</a:t>
+            </a:r>
+            <a:r>
+              <a:rPr lang="pt-BR" sz="1800" dirty="0">
+                <a:latin typeface="Times New Roman" panose="02020603050405020304" pitchFamily="18" charset="0"/>
+                <a:cs typeface="Times New Roman" panose="02020603050405020304" pitchFamily="18" charset="0"/>
+              </a:rPr>
+              <a:t> primeiras linhas do </a:t>
             </a:r>
             <a:r>
               <a:rPr lang="pt-BR" sz="1800" dirty="0" err="1">
@@ -9418,11 +9436,11 @@
               <a:buNone/>
             </a:pPr>
             <a:r>
-              <a:rPr lang="pt-BR" sz="1800" dirty="0" err="1">
-                <a:latin typeface="Times New Roman" panose="02020603050405020304" pitchFamily="18" charset="0"/>
-                <a:cs typeface="Times New Roman" panose="02020603050405020304" pitchFamily="18" charset="0"/>
-              </a:rPr>
-              <a:t>printf</a:t>
+              <a:rPr lang="pt-BR" sz="1800" dirty="0">
+                <a:latin typeface="Times New Roman" panose="02020603050405020304" pitchFamily="18" charset="0"/>
+                <a:cs typeface="Times New Roman" panose="02020603050405020304" pitchFamily="18" charset="0"/>
+              </a:rPr>
+              <a:t>print</a:t>
             </a:r>
             <a:r>
               <a:rPr lang="pt-BR" sz="1800" b="1" dirty="0">
@@ -9508,21 +9526,7 @@
                 <a:latin typeface="Times New Roman" panose="02020603050405020304" pitchFamily="18" charset="0"/>
                 <a:cs typeface="Times New Roman" panose="02020603050405020304" pitchFamily="18" charset="0"/>
               </a:rPr>
-              <a:t>['</a:t>
-            </a:r>
-            <a:r>
-              <a:rPr lang="pt-BR" sz="1800" dirty="0" err="1">
-                <a:latin typeface="Times New Roman" panose="02020603050405020304" pitchFamily="18" charset="0"/>
-                <a:cs typeface="Times New Roman" panose="02020603050405020304" pitchFamily="18" charset="0"/>
-              </a:rPr>
-              <a:t>sigla_uf_unidade_ensino</a:t>
-            </a:r>
-            <a:r>
-              <a:rPr lang="pt-BR" sz="1800" dirty="0">
-                <a:latin typeface="Times New Roman" panose="02020603050405020304" pitchFamily="18" charset="0"/>
-                <a:cs typeface="Times New Roman" panose="02020603050405020304" pitchFamily="18" charset="0"/>
-              </a:rPr>
-              <a:t>'].</a:t>
+              <a:t>['longitude'].</a:t>
             </a:r>
             <a:r>
               <a:rPr lang="pt-BR" sz="1800" b="1" dirty="0" err="1">
@@ -9592,21 +9596,7 @@
                 <a:latin typeface="Times New Roman" panose="02020603050405020304" pitchFamily="18" charset="0"/>
                 <a:cs typeface="Times New Roman" panose="02020603050405020304" pitchFamily="18" charset="0"/>
               </a:rPr>
-              <a:t>['</a:t>
-            </a:r>
-            <a:r>
-              <a:rPr lang="pt-BR" sz="1800" dirty="0" err="1">
-                <a:latin typeface="Times New Roman" panose="02020603050405020304" pitchFamily="18" charset="0"/>
-                <a:cs typeface="Times New Roman" panose="02020603050405020304" pitchFamily="18" charset="0"/>
-              </a:rPr>
-              <a:t>sigla_uf_unidade_ensino</a:t>
-            </a:r>
-            <a:r>
-              <a:rPr lang="pt-BR" sz="1800" dirty="0">
-                <a:latin typeface="Times New Roman" panose="02020603050405020304" pitchFamily="18" charset="0"/>
-                <a:cs typeface="Times New Roman" panose="02020603050405020304" pitchFamily="18" charset="0"/>
-              </a:rPr>
-              <a:t>'].</a:t>
+              <a:t>['longitude'].</a:t>
             </a:r>
             <a:r>
               <a:rPr lang="pt-BR" sz="1800" b="1" dirty="0" err="1">

</xml_diff>